<commit_message>
Sunum: referans slaydına portföy görselleri
- TAI Ankara Lodgings vaziyet perspektifi, Kahramankazan Kentsel Dönüşüm ve
  Kent Merkezi görselleri docs/portfoy PDF'inden kırpılıyor (gorseller.py)
- Roller portföyle doğrulandı: GIA ve Serapınar tasarım ve yapım, diğerleri tasarım

Co-Authored-By: Claude Opus 5.5 <noreply@anthropic.com>
Claude-Session: https://claude.ai/code/session_017Bigq3wz42fLbgMKrFhXXw
</commit_message>
<xml_diff>
--- a/reports/Örencik yaşam alanı sunumu.pptx
+++ b/reports/Örencik yaşam alanı sunumu.pptx
@@ -130,14 +130,14 @@
   <p:extLst>
     <p:ext uri="{521415D9-36F7-43E2-AB2F-B90AF26B5E84}">
       <p14:sectionLst xmlns:p14="http://schemas.microsoft.com/office/powerpoint/2010/main">
-        <p14:section name="Giriş" id="{d92637f7-b7de-d0b6-188e-d8894b072d75}">
+        <p14:section name="Giriş" id="{2f02bf5c-0d16-58b7-0ea6-16ebd2e48342}">
           <p14:sldIdLst>
             <p14:sldId id="256"/>
             <p14:sldId id="257"/>
             <p14:sldId id="258"/>
           </p14:sldIdLst>
         </p14:section>
-        <p14:section name="Yer ve saha" id="{f3d25fd1-6214-654c-c597-1fd7039c6a26}">
+        <p14:section name="Yer ve saha" id="{612fb2b4-d213-e7d7-7f67-1bcf7693e54c}">
           <p14:sldIdLst>
             <p14:sldId id="259"/>
             <p14:sldId id="260"/>
@@ -146,7 +146,7 @@
             <p14:sldId id="263"/>
           </p14:sldIdLst>
         </p14:section>
-        <p14:section name="Yaşam alanı" id="{2a8984db-92ab-e643-228d-24ed0c1649bb}">
+        <p14:section name="Yaşam alanı" id="{5a22ea73-0361-8857-8b0c-8dea7633f052}">
           <p14:sldIdLst>
             <p14:sldId id="264"/>
             <p14:sldId id="265"/>
@@ -160,13 +160,13 @@
             <p14:sldId id="273"/>
           </p14:sldIdLst>
         </p14:section>
-        <p14:section name="Yatırım ve fayda" id="{27529f25-8f17-bbc8-647e-2569e5557152}">
+        <p14:section name="Yatırım ve fayda" id="{834d80ea-2b23-f896-4cd3-bd69bc99d58c}">
           <p14:sldIdLst>
             <p14:sldId id="274"/>
             <p14:sldId id="275"/>
           </p14:sldIdLst>
         </p14:section>
-        <p14:section name="Uygulama" id="{3bedae95-6181-47ae-3b19-095478678299}">
+        <p14:section name="Uygulama" id="{9029d943-52ea-2ffb-39b1-3f3d986ee5b2}">
           <p14:sldIdLst>
             <p14:sldId id="276"/>
             <p14:sldId id="277"/>
@@ -19327,11 +19327,11 @@
         <p:spPr>
           <a:xfrm>
             <a:off x="548640" y="1600200"/>
-            <a:ext cx="5852160" cy="2057400"/>
+            <a:ext cx="5943600" cy="3429000"/>
           </a:xfrm>
           <a:prstGeom prst="roundRect">
             <a:avLst>
-              <a:gd name="adj" fmla="val 3556"/>
+              <a:gd name="adj" fmla="val 2133"/>
             </a:avLst>
           </a:prstGeom>
           <a:solidFill>
@@ -19347,29 +19347,9 @@
           </a:effectLst>
         </p:spPr>
       </p:sp>
-      <p:sp>
-        <p:nvSpPr>
-          <p:cNvPr id="5" name="İkon zemini"/>
-          <p:cNvSpPr/>
-          <p:nvPr/>
-        </p:nvSpPr>
-        <p:spPr>
-          <a:xfrm>
-            <a:off x="777240" y="1874520"/>
-            <a:ext cx="685800" cy="685800"/>
-          </a:xfrm>
-          <a:prstGeom prst="ellipse">
-            <a:avLst/>
-          </a:prstGeom>
-          <a:solidFill>
-            <a:schemeClr val="accent1"/>
-          </a:solidFill>
-          <a:ln/>
-        </p:spPr>
-      </p:sp>
       <p:pic>
         <p:nvPicPr>
-          <p:cNvPr id="6" name="İkon FaHouseChimney" descr="preencoded.png">    </p:cNvPr>
+          <p:cNvPr id="5" name="TAI Ankara Lodgings vaziyet perspektifi" descr="/home/user/sunum/araclar/sunum/assets/ref_tai_ankara.jpg">    </p:cNvPr>
           <p:cNvPicPr>
             <a:picLocks noChangeAspect="1"/>
           </p:cNvPicPr>
@@ -19383,14 +19363,61 @@
         </p:blipFill>
         <p:spPr>
           <a:xfrm>
-            <a:off x="941832" y="2039112"/>
-            <a:ext cx="356616" cy="356616"/>
+            <a:off x="548640" y="1600200"/>
+            <a:ext cx="5943600" cy="2366083"/>
           </a:xfrm>
           <a:prstGeom prst="rect">
             <a:avLst/>
           </a:prstGeom>
         </p:spPr>
       </p:pic>
+      <p:sp>
+        <p:nvSpPr>
+          <p:cNvPr id="6" name="Text 3"/>
+          <p:cNvSpPr txBox="1"/>
+          <p:nvPr/>
+        </p:nvSpPr>
+        <p:spPr>
+          <a:xfrm>
+            <a:off x="777240" y="4103443"/>
+            <a:ext cx="5486400" cy="347472"/>
+          </a:xfrm>
+          <a:prstGeom prst="rect">
+            <a:avLst/>
+          </a:prstGeom>
+          <a:noFill/>
+          <a:ln/>
+        </p:spPr>
+        <p:txBody>
+          <a:bodyPr wrap="square" lIns="0" tIns="0" rIns="0" bIns="0" rtlCol="0" anchor="ctr"/>
+          <a:lstStyle/>
+          <a:p>
+            <a:pPr indent="0" marL="0">
+              <a:buNone/>
+            </a:pPr>
+            <a:r>
+              <a:rPr lang="en-US" sz="1800" b="1" dirty="0">
+                <a:solidFill>
+                  <a:schemeClr val="tx2"/>
+                </a:solidFill>
+              </a:rPr>
+              <a:t>TAI Ankara Lodgings  </a:t>
+            </a:r>
+            <a:pPr indent="0" marL="0">
+              <a:buNone/>
+            </a:pPr>
+            <a:r>
+              <a:rPr lang="en-US" sz="1300" b="1" dirty="0">
+                <a:solidFill>
+                  <a:schemeClr val="accent1"/>
+                </a:solidFill>
+              </a:rPr>
+              <a:t>Kahramankazan · 2022 · 400.000 m² · 1.500 konut</a:t>
+            </a:r>
+            <a:endParaRPr lang="en-US" sz="1400" dirty="0"/>
+          </a:p>
+        </p:txBody>
+      </p:sp>
       <p:sp>
         <p:nvSpPr>
           <p:cNvPr id="7" name="Text 4"/>
@@ -19399,8 +19426,8 @@
         </p:nvSpPr>
         <p:spPr>
           <a:xfrm>
-            <a:off x="1645920" y="1828800"/>
-            <a:ext cx="4572000" cy="365760"/>
+            <a:off x="777240" y="4487491"/>
+            <a:ext cx="5486400" cy="566928"/>
           </a:xfrm>
           <a:prstGeom prst="rect">
             <a:avLst/>
@@ -19416,84 +19443,12 @@
               <a:buNone/>
             </a:pPr>
             <a:r>
-              <a:rPr lang="en-US" sz="1900" b="1" dirty="0">
-                <a:solidFill>
-                  <a:schemeClr val="tx2"/>
+              <a:rPr lang="en-US" sz="1400" dirty="0">
+                <a:solidFill>
+                  <a:schemeClr val="tx1"/>
                 </a:solidFill>
               </a:rPr>
-              <a:t>TAI Ankara Lodgings</a:t>
-            </a:r>
-            <a:endParaRPr lang="en-US" sz="1900" dirty="0"/>
-          </a:p>
-        </p:txBody>
-      </p:sp>
-      <p:sp>
-        <p:nvSpPr>
-          <p:cNvPr id="8" name="Text 5"/>
-          <p:cNvSpPr txBox="1"/>
-          <p:nvPr/>
-        </p:nvSpPr>
-        <p:spPr>
-          <a:xfrm>
-            <a:off x="1645920" y="2221992"/>
-            <a:ext cx="4572000" cy="320040"/>
-          </a:xfrm>
-          <a:prstGeom prst="rect">
-            <a:avLst/>
-          </a:prstGeom>
-          <a:noFill/>
-          <a:ln/>
-        </p:spPr>
-        <p:txBody>
-          <a:bodyPr wrap="square" lIns="0" tIns="0" rIns="0" bIns="0" rtlCol="0" anchor="t"/>
-          <a:lstStyle/>
-          <a:p>
-            <a:pPr indent="0" marL="0">
-              <a:buNone/>
-            </a:pPr>
-            <a:r>
-              <a:rPr lang="en-US" sz="1300" b="1" dirty="0">
-                <a:solidFill>
-                  <a:schemeClr val="accent1"/>
-                </a:solidFill>
-              </a:rPr>
-              <a:t>Kahramankazan · 2022 · 400.000 m² · 1.500 konut</a:t>
-            </a:r>
-            <a:endParaRPr lang="en-US" sz="1300" dirty="0"/>
-          </a:p>
-        </p:txBody>
-      </p:sp>
-      <p:sp>
-        <p:nvSpPr>
-          <p:cNvPr id="9" name="Text 6"/>
-          <p:cNvSpPr txBox="1"/>
-          <p:nvPr/>
-        </p:nvSpPr>
-        <p:spPr>
-          <a:xfrm>
-            <a:off x="1645920" y="2606040"/>
-            <a:ext cx="4572000" cy="960120"/>
-          </a:xfrm>
-          <a:prstGeom prst="rect">
-            <a:avLst/>
-          </a:prstGeom>
-          <a:noFill/>
-          <a:ln/>
-        </p:spPr>
-        <p:txBody>
-          <a:bodyPr wrap="square" lIns="0" tIns="0" rIns="0" bIns="0" rtlCol="0" anchor="t"/>
-          <a:lstStyle/>
-          <a:p>
-            <a:pPr indent="0" marL="0">
-              <a:buNone/>
-            </a:pPr>
-            <a:r>
-              <a:rPr lang="en-US" sz="1400" dirty="0">
-                <a:solidFill>
-                  <a:schemeClr val="tx1"/>
-                </a:solidFill>
-              </a:rPr>
-              <a:t>TUSAŞ için yeni konut mahallesi. Ortada yeşil bir omurga; okul, sağlık ocağı, kütüphane ve spor tesisleri yürüme mesafesinde.</a:t>
+              <a:t>TUSAŞ için yeni konut mahallesi: yeşil bir omurga; okul, sağlık ocağı, kütüphane ve spor yürüme mesafesinde.</a:t>
             </a:r>
             <a:endParaRPr lang="en-US" sz="1400" dirty="0"/>
           </a:p>
@@ -19501,18 +19456,18 @@
       </p:sp>
       <p:sp>
         <p:nvSpPr>
-          <p:cNvPr id="10" name="Kart"/>
+          <p:cNvPr id="8" name="Kart"/>
           <p:cNvSpPr/>
           <p:nvPr/>
         </p:nvSpPr>
         <p:spPr>
           <a:xfrm>
-            <a:off x="548640" y="3840480"/>
-            <a:ext cx="5852160" cy="2057400"/>
+            <a:off x="548640" y="5212080"/>
+            <a:ext cx="5943600" cy="777240"/>
           </a:xfrm>
           <a:prstGeom prst="roundRect">
             <a:avLst>
-              <a:gd name="adj" fmla="val 3556"/>
+              <a:gd name="adj" fmla="val 9412"/>
             </a:avLst>
           </a:prstGeom>
           <a:solidFill>
@@ -19530,14 +19485,14 @@
       </p:sp>
       <p:sp>
         <p:nvSpPr>
-          <p:cNvPr id="11" name="İkon zemini"/>
+          <p:cNvPr id="9" name="İkon zemini"/>
           <p:cNvSpPr/>
           <p:nvPr/>
         </p:nvSpPr>
         <p:spPr>
           <a:xfrm>
-            <a:off x="777240" y="4114800"/>
-            <a:ext cx="685800" cy="685800"/>
+            <a:off x="731520" y="5330952"/>
+            <a:ext cx="548640" cy="548640"/>
           </a:xfrm>
           <a:prstGeom prst="ellipse">
             <a:avLst/>
@@ -19550,7 +19505,7 @@
       </p:sp>
       <p:pic>
         <p:nvPicPr>
-          <p:cNvPr id="12" name="İkon FaIndustry" descr="preencoded.png">    </p:cNvPr>
+          <p:cNvPr id="10" name="İkon FaIndustry" descr="preencoded.png">    </p:cNvPr>
           <p:cNvPicPr>
             <a:picLocks noChangeAspect="1"/>
           </p:cNvPicPr>
@@ -19564,8 +19519,8 @@
         </p:blipFill>
         <p:spPr>
           <a:xfrm>
-            <a:off x="941832" y="4279392"/>
-            <a:ext cx="356616" cy="356616"/>
+            <a:off x="863194" y="5462626"/>
+            <a:ext cx="285293" cy="285293"/>
           </a:xfrm>
           <a:prstGeom prst="rect">
             <a:avLst/>
@@ -19574,14 +19529,14 @@
       </p:pic>
       <p:sp>
         <p:nvSpPr>
-          <p:cNvPr id="13" name="Text 9"/>
+          <p:cNvPr id="11" name="Text 7"/>
           <p:cNvSpPr txBox="1"/>
           <p:nvPr/>
         </p:nvSpPr>
         <p:spPr>
           <a:xfrm>
-            <a:off x="1645920" y="4069080"/>
-            <a:ext cx="4572000" cy="365760"/>
+            <a:off x="1417320" y="5285232"/>
+            <a:ext cx="4892040" cy="658368"/>
           </a:xfrm>
           <a:prstGeom prst="rect">
             <a:avLst/>
@@ -19590,70 +19545,96 @@
           <a:ln/>
         </p:spPr>
         <p:txBody>
-          <a:bodyPr wrap="square" lIns="0" tIns="0" rIns="0" bIns="0" rtlCol="0" anchor="t"/>
+          <a:bodyPr wrap="square" lIns="0" tIns="0" rIns="0" bIns="0" rtlCol="0" anchor="ctr"/>
           <a:lstStyle/>
           <a:p>
             <a:pPr indent="0" marL="0">
               <a:buNone/>
             </a:pPr>
             <a:r>
-              <a:rPr lang="en-US" sz="1900" b="1" dirty="0">
+              <a:rPr lang="en-US" sz="1500" b="1" dirty="0">
                 <a:solidFill>
                   <a:schemeClr val="tx2"/>
                 </a:solidFill>
               </a:rPr>
               <a:t>TAI Kahramanmaraş Lodgings and Factory</a:t>
             </a:r>
-            <a:endParaRPr lang="en-US" sz="1900" dirty="0"/>
-          </a:p>
-        </p:txBody>
-      </p:sp>
-      <p:sp>
-        <p:nvSpPr>
-          <p:cNvPr id="14" name="Text 10"/>
-          <p:cNvSpPr txBox="1"/>
-          <p:nvPr/>
-        </p:nvSpPr>
-        <p:spPr>
-          <a:xfrm>
-            <a:off x="1645920" y="4462272"/>
-            <a:ext cx="4572000" cy="320040"/>
-          </a:xfrm>
-          <a:prstGeom prst="rect">
-            <a:avLst/>
-          </a:prstGeom>
-          <a:noFill/>
-          <a:ln/>
-        </p:spPr>
-        <p:txBody>
-          <a:bodyPr wrap="square" lIns="0" tIns="0" rIns="0" bIns="0" rtlCol="0" anchor="t"/>
-          <a:lstStyle/>
+            <a:endParaRPr lang="en-US" sz="1400" dirty="0"/>
+          </a:p>
           <a:p>
             <a:pPr indent="0" marL="0">
               <a:buNone/>
             </a:pPr>
             <a:r>
-              <a:rPr lang="en-US" sz="1300" b="1" dirty="0">
-                <a:solidFill>
-                  <a:schemeClr val="accent1"/>
+              <a:rPr lang="en-US" sz="1300" dirty="0">
+                <a:solidFill>
+                  <a:schemeClr val="tx1"/>
                 </a:solidFill>
               </a:rPr>
-              <a:t>Kahramanmaraş · TUSAŞ lojmanları ve fabrikası</a:t>
-            </a:r>
-            <a:endParaRPr lang="en-US" sz="1300" dirty="0"/>
-          </a:p>
-        </p:txBody>
-      </p:sp>
-      <p:sp>
-        <p:nvSpPr>
-          <p:cNvPr id="15" name="Text 11"/>
+              <a:t>TUSAŞ lojmanları ve fabrikası: çalışan konutu ile üretim tesisini birlikte ele aldık.</a:t>
+            </a:r>
+            <a:endParaRPr lang="en-US" sz="1400" dirty="0"/>
+          </a:p>
+        </p:txBody>
+      </p:sp>
+      <p:pic>
+        <p:nvPicPr>
+          <p:cNvPr id="12" name="Kahramankazan Kentsel Dönüşüm" descr="/home/user/sunum/araclar/sunum/assets/ref_kentsel_donusum.jpg">    </p:cNvPr>
+          <p:cNvPicPr>
+            <a:picLocks noChangeAspect="1"/>
+          </p:cNvPicPr>
+          <p:nvPr/>
+        </p:nvPicPr>
+        <p:blipFill>
+          <a:blip r:embed="rId3"/>
+          <a:stretch>
+            <a:fillRect/>
+          </a:stretch>
+        </p:blipFill>
+        <p:spPr>
+          <a:xfrm>
+            <a:off x="6812280" y="1600200"/>
+            <a:ext cx="2323948" cy="1206619"/>
+          </a:xfrm>
+          <a:prstGeom prst="rect">
+            <a:avLst/>
+          </a:prstGeom>
+        </p:spPr>
+      </p:pic>
+      <p:pic>
+        <p:nvPicPr>
+          <p:cNvPr id="13" name="Kahramankazan Kent Merkezi" descr="/home/user/sunum/araclar/sunum/assets/ref_kent_merkezi.jpg">    </p:cNvPr>
+          <p:cNvPicPr>
+            <a:picLocks noChangeAspect="1"/>
+          </p:cNvPicPr>
+          <p:nvPr/>
+        </p:nvPicPr>
+        <p:blipFill>
+          <a:blip r:embed="rId4"/>
+          <a:stretch>
+            <a:fillRect/>
+          </a:stretch>
+        </p:blipFill>
+        <p:spPr>
+          <a:xfrm>
+            <a:off x="9319108" y="1600200"/>
+            <a:ext cx="2323948" cy="1206619"/>
+          </a:xfrm>
+          <a:prstGeom prst="rect">
+            <a:avLst/>
+          </a:prstGeom>
+        </p:spPr>
+      </p:pic>
+      <p:sp>
+        <p:nvSpPr>
+          <p:cNvPr id="14" name="Text 8"/>
           <p:cNvSpPr txBox="1"/>
           <p:nvPr/>
         </p:nvSpPr>
         <p:spPr>
           <a:xfrm>
-            <a:off x="1645920" y="4846320"/>
-            <a:ext cx="4572000" cy="960120"/>
+            <a:off x="6812280" y="2852539"/>
+            <a:ext cx="2323948" cy="256032"/>
           </a:xfrm>
           <a:prstGeom prst="rect">
             <a:avLst/>
@@ -19669,27 +19650,27 @@
               <a:buNone/>
             </a:pPr>
             <a:r>
-              <a:rPr lang="en-US" sz="1400" dirty="0">
-                <a:solidFill>
-                  <a:schemeClr val="tx1"/>
+              <a:rPr lang="en-US" sz="1100" dirty="0">
+                <a:solidFill>
+                  <a:schemeClr val="accent5"/>
                 </a:solidFill>
               </a:rPr>
-              <a:t>Çalışan konutunu ve üretim tesisini birlikte ele aldık: Örencik'teki iş ve yaşam ilişkisine doğrudan emsal.</a:t>
-            </a:r>
-            <a:endParaRPr lang="en-US" sz="1400" dirty="0"/>
-          </a:p>
-        </p:txBody>
-      </p:sp>
-      <p:sp>
-        <p:nvSpPr>
-          <p:cNvPr id="16" name="Text 12"/>
+              <a:t>Kentsel Dönüşüm</a:t>
+            </a:r>
+            <a:endParaRPr lang="en-US" sz="1100" dirty="0"/>
+          </a:p>
+        </p:txBody>
+      </p:sp>
+      <p:sp>
+        <p:nvSpPr>
+          <p:cNvPr id="15" name="Text 9"/>
           <p:cNvSpPr txBox="1"/>
           <p:nvPr/>
         </p:nvSpPr>
         <p:spPr>
           <a:xfrm>
-            <a:off x="6675120" y="1600200"/>
-            <a:ext cx="4967935" cy="320040"/>
+            <a:off x="9319108" y="2852539"/>
+            <a:ext cx="2323948" cy="256032"/>
           </a:xfrm>
           <a:prstGeom prst="rect">
             <a:avLst/>
@@ -19705,14 +19686,14 @@
               <a:buNone/>
             </a:pPr>
             <a:r>
-              <a:rPr lang="en-US" sz="1700" b="1" dirty="0">
-                <a:solidFill>
-                  <a:schemeClr val="tx2"/>
+              <a:rPr lang="en-US" sz="1100" dirty="0">
+                <a:solidFill>
+                  <a:schemeClr val="accent5"/>
                 </a:solidFill>
               </a:rPr>
-              <a:t>Bölgede ve sektörde diğer işlerimiz</a:t>
-            </a:r>
-            <a:endParaRPr lang="en-US" sz="1700" dirty="0"/>
+              <a:t>Kent Merkezi</a:t>
+            </a:r>
+            <a:endParaRPr lang="en-US" sz="1100" dirty="0"/>
           </a:p>
         </p:txBody>
       </p:sp>
@@ -19731,8 +19712,8 @@
           </p:nvPr>
         </p:nvGraphicFramePr>
         <p:xfrm>
-          <a:off x="6675120" y="2057400"/>
-          <a:ext cx="4967935" cy="914400"/>
+          <a:off x="6812280" y="3218299"/>
+          <a:ext cx="4830775" cy="914400"/>
         </p:xfrm>
         <a:graphic>
           <a:graphicData uri="http://schemas.openxmlformats.org/drawingml/2006/table">
@@ -19740,11 +19721,11 @@
               <a:tblPr/>
               <a:tblGrid>
                 <a:gridCol w="2240280"/>
-                <a:gridCol w="548640"/>
-                <a:gridCol w="1005840"/>
-                <a:gridCol w="1173175"/>
+                <a:gridCol w="502920"/>
+                <a:gridCol w="987552"/>
+                <a:gridCol w="1100023"/>
               </a:tblGrid>
-              <a:tr h="502920">
+              <a:tr h="384048">
                 <a:tc>
                   <a:txBody>
                     <a:bodyPr/>
@@ -19764,7 +19745,7 @@
                       <a:endParaRPr lang="en-US" sz="1300" dirty="0"/>
                     </a:p>
                   </a:txBody>
-                  <a:tcPr marL="73152" marR="73152" marT="36576" marB="36576" anchor="ctr">
+                  <a:tcPr marL="64008" marR="64008" marT="27432" marB="27432" anchor="ctr">
                     <a:lnL w="9525" cap="flat" cmpd="sng" algn="ctr">
                       <a:solidFill>
                         <a:srgbClr val="DDD8CC"/>
@@ -19825,7 +19806,7 @@
                       <a:endParaRPr lang="en-US" sz="1300" dirty="0"/>
                     </a:p>
                   </a:txBody>
-                  <a:tcPr marL="73152" marR="73152" marT="36576" marB="36576" anchor="ctr">
+                  <a:tcPr marL="64008" marR="64008" marT="27432" marB="27432" anchor="ctr">
                     <a:lnL w="9525" cap="flat" cmpd="sng" algn="ctr">
                       <a:solidFill>
                         <a:srgbClr val="DDD8CC"/>
@@ -19886,7 +19867,7 @@
                       <a:endParaRPr lang="en-US" sz="1300" dirty="0"/>
                     </a:p>
                   </a:txBody>
-                  <a:tcPr marL="73152" marR="73152" marT="36576" marB="36576" anchor="ctr">
+                  <a:tcPr marL="64008" marR="64008" marT="27432" marB="27432" anchor="ctr">
                     <a:lnL w="9525" cap="flat" cmpd="sng" algn="ctr">
                       <a:solidFill>
                         <a:srgbClr val="DDD8CC"/>
@@ -19947,7 +19928,7 @@
                       <a:endParaRPr lang="en-US" sz="1300" dirty="0"/>
                     </a:p>
                   </a:txBody>
-                  <a:tcPr marL="73152" marR="73152" marT="36576" marB="36576" anchor="ctr">
+                  <a:tcPr marL="64008" marR="64008" marT="27432" marB="27432" anchor="ctr">
                     <a:lnL w="9525" cap="flat" cmpd="sng" algn="ctr">
                       <a:solidFill>
                         <a:srgbClr val="DDD8CC"/>
@@ -19990,7 +19971,7 @@
                   </a:tcPr>
                 </a:tc>
               </a:tr>
-              <a:tr h="502920">
+              <a:tr h="457200">
                 <a:tc>
                   <a:txBody>
                     <a:bodyPr/>
@@ -20010,7 +19991,7 @@
                       <a:endParaRPr lang="en-US" sz="1300" dirty="0"/>
                     </a:p>
                   </a:txBody>
-                  <a:tcPr marL="73152" marR="73152" marT="36576" marB="36576" anchor="ctr">
+                  <a:tcPr marL="64008" marR="64008" marT="27432" marB="27432" anchor="ctr">
                     <a:lnL w="9525" cap="flat" cmpd="sng" algn="ctr">
                       <a:solidFill>
                         <a:srgbClr val="DDD8CC"/>
@@ -20071,7 +20052,7 @@
                       <a:endParaRPr lang="en-US" sz="1300" dirty="0"/>
                     </a:p>
                   </a:txBody>
-                  <a:tcPr marL="73152" marR="73152" marT="36576" marB="36576" anchor="ctr">
+                  <a:tcPr marL="64008" marR="64008" marT="27432" marB="27432" anchor="ctr">
                     <a:lnL w="9525" cap="flat" cmpd="sng" algn="ctr">
                       <a:solidFill>
                         <a:srgbClr val="DDD8CC"/>
@@ -20132,7 +20113,7 @@
                       <a:endParaRPr lang="en-US" sz="1300" dirty="0"/>
                     </a:p>
                   </a:txBody>
-                  <a:tcPr marL="73152" marR="73152" marT="36576" marB="36576" anchor="ctr">
+                  <a:tcPr marL="64008" marR="64008" marT="27432" marB="27432" anchor="ctr">
                     <a:lnL w="9525" cap="flat" cmpd="sng" algn="ctr">
                       <a:solidFill>
                         <a:srgbClr val="DDD8CC"/>
@@ -20193,7 +20174,7 @@
                       <a:endParaRPr lang="en-US" sz="1300" dirty="0"/>
                     </a:p>
                   </a:txBody>
-                  <a:tcPr marL="73152" marR="73152" marT="36576" marB="36576" anchor="ctr">
+                  <a:tcPr marL="64008" marR="64008" marT="27432" marB="27432" anchor="ctr">
                     <a:lnL w="9525" cap="flat" cmpd="sng" algn="ctr">
                       <a:solidFill>
                         <a:srgbClr val="DDD8CC"/>
@@ -20236,7 +20217,7 @@
                   </a:tcPr>
                 </a:tc>
               </a:tr>
-              <a:tr h="502920">
+              <a:tr h="457200">
                 <a:tc>
                   <a:txBody>
                     <a:bodyPr/>
@@ -20256,7 +20237,7 @@
                       <a:endParaRPr lang="en-US" sz="1300" dirty="0"/>
                     </a:p>
                   </a:txBody>
-                  <a:tcPr marL="73152" marR="73152" marT="36576" marB="36576" anchor="ctr">
+                  <a:tcPr marL="64008" marR="64008" marT="27432" marB="27432" anchor="ctr">
                     <a:lnL w="9525" cap="flat" cmpd="sng" algn="ctr">
                       <a:solidFill>
                         <a:srgbClr val="DDD8CC"/>
@@ -20317,7 +20298,7 @@
                       <a:endParaRPr lang="en-US" sz="1300" dirty="0"/>
                     </a:p>
                   </a:txBody>
-                  <a:tcPr marL="73152" marR="73152" marT="36576" marB="36576" anchor="ctr">
+                  <a:tcPr marL="64008" marR="64008" marT="27432" marB="27432" anchor="ctr">
                     <a:lnL w="9525" cap="flat" cmpd="sng" algn="ctr">
                       <a:solidFill>
                         <a:srgbClr val="DDD8CC"/>
@@ -20378,7 +20359,7 @@
                       <a:endParaRPr lang="en-US" sz="1300" dirty="0"/>
                     </a:p>
                   </a:txBody>
-                  <a:tcPr marL="73152" marR="73152" marT="36576" marB="36576" anchor="ctr">
+                  <a:tcPr marL="64008" marR="64008" marT="27432" marB="27432" anchor="ctr">
                     <a:lnL w="9525" cap="flat" cmpd="sng" algn="ctr">
                       <a:solidFill>
                         <a:srgbClr val="DDD8CC"/>
@@ -20439,7 +20420,7 @@
                       <a:endParaRPr lang="en-US" sz="1300" dirty="0"/>
                     </a:p>
                   </a:txBody>
-                  <a:tcPr marL="73152" marR="73152" marT="36576" marB="36576" anchor="ctr">
+                  <a:tcPr marL="64008" marR="64008" marT="27432" marB="27432" anchor="ctr">
                     <a:lnL w="9525" cap="flat" cmpd="sng" algn="ctr">
                       <a:solidFill>
                         <a:srgbClr val="DDD8CC"/>
@@ -20482,7 +20463,7 @@
                   </a:tcPr>
                 </a:tc>
               </a:tr>
-              <a:tr h="502920">
+              <a:tr h="457200">
                 <a:tc>
                   <a:txBody>
                     <a:bodyPr/>
@@ -20502,7 +20483,7 @@
                       <a:endParaRPr lang="en-US" sz="1300" dirty="0"/>
                     </a:p>
                   </a:txBody>
-                  <a:tcPr marL="73152" marR="73152" marT="36576" marB="36576" anchor="ctr">
+                  <a:tcPr marL="64008" marR="64008" marT="27432" marB="27432" anchor="ctr">
                     <a:lnL w="9525" cap="flat" cmpd="sng" algn="ctr">
                       <a:solidFill>
                         <a:srgbClr val="DDD8CC"/>
@@ -20563,7 +20544,7 @@
                       <a:endParaRPr lang="en-US" sz="1300" dirty="0"/>
                     </a:p>
                   </a:txBody>
-                  <a:tcPr marL="73152" marR="73152" marT="36576" marB="36576" anchor="ctr">
+                  <a:tcPr marL="64008" marR="64008" marT="27432" marB="27432" anchor="ctr">
                     <a:lnL w="9525" cap="flat" cmpd="sng" algn="ctr">
                       <a:solidFill>
                         <a:srgbClr val="DDD8CC"/>
@@ -20624,7 +20605,7 @@
                       <a:endParaRPr lang="en-US" sz="1300" dirty="0"/>
                     </a:p>
                   </a:txBody>
-                  <a:tcPr marL="73152" marR="73152" marT="36576" marB="36576" anchor="ctr">
+                  <a:tcPr marL="64008" marR="64008" marT="27432" marB="27432" anchor="ctr">
                     <a:lnL w="9525" cap="flat" cmpd="sng" algn="ctr">
                       <a:solidFill>
                         <a:srgbClr val="DDD8CC"/>
@@ -20685,7 +20666,7 @@
                       <a:endParaRPr lang="en-US" sz="1300" dirty="0"/>
                     </a:p>
                   </a:txBody>
-                  <a:tcPr marL="73152" marR="73152" marT="36576" marB="36576" anchor="ctr">
+                  <a:tcPr marL="64008" marR="64008" marT="27432" marB="27432" anchor="ctr">
                     <a:lnL w="9525" cap="flat" cmpd="sng" algn="ctr">
                       <a:solidFill>
                         <a:srgbClr val="DDD8CC"/>
@@ -20728,7 +20709,7 @@
                   </a:tcPr>
                 </a:tc>
               </a:tr>
-              <a:tr h="502920">
+              <a:tr h="457200">
                 <a:tc>
                   <a:txBody>
                     <a:bodyPr/>
@@ -20748,7 +20729,7 @@
                       <a:endParaRPr lang="en-US" sz="1300" dirty="0"/>
                     </a:p>
                   </a:txBody>
-                  <a:tcPr marL="73152" marR="73152" marT="36576" marB="36576" anchor="ctr">
+                  <a:tcPr marL="64008" marR="64008" marT="27432" marB="27432" anchor="ctr">
                     <a:lnL w="9525" cap="flat" cmpd="sng" algn="ctr">
                       <a:solidFill>
                         <a:srgbClr val="DDD8CC"/>
@@ -20809,7 +20790,7 @@
                       <a:endParaRPr lang="en-US" sz="1300" dirty="0"/>
                     </a:p>
                   </a:txBody>
-                  <a:tcPr marL="73152" marR="73152" marT="36576" marB="36576" anchor="ctr">
+                  <a:tcPr marL="64008" marR="64008" marT="27432" marB="27432" anchor="ctr">
                     <a:lnL w="9525" cap="flat" cmpd="sng" algn="ctr">
                       <a:solidFill>
                         <a:srgbClr val="DDD8CC"/>
@@ -20870,7 +20851,7 @@
                       <a:endParaRPr lang="en-US" sz="1300" dirty="0"/>
                     </a:p>
                   </a:txBody>
-                  <a:tcPr marL="73152" marR="73152" marT="36576" marB="36576" anchor="ctr">
+                  <a:tcPr marL="64008" marR="64008" marT="27432" marB="27432" anchor="ctr">
                     <a:lnL w="9525" cap="flat" cmpd="sng" algn="ctr">
                       <a:solidFill>
                         <a:srgbClr val="DDD8CC"/>
@@ -20931,499 +20912,7 @@
                       <a:endParaRPr lang="en-US" sz="1300" dirty="0"/>
                     </a:p>
                   </a:txBody>
-                  <a:tcPr marL="73152" marR="73152" marT="36576" marB="36576" anchor="ctr">
-                    <a:lnL w="9525" cap="flat" cmpd="sng" algn="ctr">
-                      <a:solidFill>
-                        <a:srgbClr val="DDD8CC"/>
-                      </a:solidFill>
-                      <a:prstDash val="solid"/>
-                      <a:round/>
-                      <a:headEnd type="none" w="med" len="med"/>
-                      <a:tailEnd type="none" w="med" len="med"/>
-                    </a:lnL>
-                    <a:lnR w="9525" cap="flat" cmpd="sng" algn="ctr">
-                      <a:solidFill>
-                        <a:srgbClr val="DDD8CC"/>
-                      </a:solidFill>
-                      <a:prstDash val="solid"/>
-                      <a:round/>
-                      <a:headEnd type="none" w="med" len="med"/>
-                      <a:tailEnd type="none" w="med" len="med"/>
-                    </a:lnR>
-                    <a:lnT w="9525" cap="flat" cmpd="sng" algn="ctr">
-                      <a:solidFill>
-                        <a:srgbClr val="DDD8CC"/>
-                      </a:solidFill>
-                      <a:prstDash val="solid"/>
-                      <a:round/>
-                      <a:headEnd type="none" w="med" len="med"/>
-                      <a:tailEnd type="none" w="med" len="med"/>
-                    </a:lnT>
-                    <a:lnB w="9525" cap="flat" cmpd="sng" algn="ctr">
-                      <a:solidFill>
-                        <a:srgbClr val="DDD8CC"/>
-                      </a:solidFill>
-                      <a:prstDash val="solid"/>
-                      <a:round/>
-                      <a:headEnd type="none" w="med" len="med"/>
-                      <a:tailEnd type="none" w="med" len="med"/>
-                    </a:lnB>
-                    <a:solidFill>
-                      <a:srgbClr val="FFFFFF"/>
-                    </a:solidFill>
-                  </a:tcPr>
-                </a:tc>
-              </a:tr>
-              <a:tr h="502920">
-                <a:tc>
-                  <a:txBody>
-                    <a:bodyPr/>
-                    <a:lstStyle/>
-                    <a:p>
-                      <a:pPr algn="l" indent="0" marL="0">
-                        <a:buNone/>
-                      </a:pPr>
-                      <a:r>
-                        <a:rPr lang="en-US" sz="1300" dirty="0">
-                          <a:solidFill>
-                            <a:srgbClr val="1B2430"/>
-                          </a:solidFill>
-                        </a:rPr>
-                        <a:t>MKE Teknopark ve Genel Müdürlük</a:t>
-                      </a:r>
-                      <a:endParaRPr lang="en-US" sz="1300" dirty="0"/>
-                    </a:p>
-                  </a:txBody>
-                  <a:tcPr marL="73152" marR="73152" marT="36576" marB="36576" anchor="ctr">
-                    <a:lnL w="9525" cap="flat" cmpd="sng" algn="ctr">
-                      <a:solidFill>
-                        <a:srgbClr val="DDD8CC"/>
-                      </a:solidFill>
-                      <a:prstDash val="solid"/>
-                      <a:round/>
-                      <a:headEnd type="none" w="med" len="med"/>
-                      <a:tailEnd type="none" w="med" len="med"/>
-                    </a:lnL>
-                    <a:lnR w="9525" cap="flat" cmpd="sng" algn="ctr">
-                      <a:solidFill>
-                        <a:srgbClr val="DDD8CC"/>
-                      </a:solidFill>
-                      <a:prstDash val="solid"/>
-                      <a:round/>
-                      <a:headEnd type="none" w="med" len="med"/>
-                      <a:tailEnd type="none" w="med" len="med"/>
-                    </a:lnR>
-                    <a:lnT w="9525" cap="flat" cmpd="sng" algn="ctr">
-                      <a:solidFill>
-                        <a:srgbClr val="DDD8CC"/>
-                      </a:solidFill>
-                      <a:prstDash val="solid"/>
-                      <a:round/>
-                      <a:headEnd type="none" w="med" len="med"/>
-                      <a:tailEnd type="none" w="med" len="med"/>
-                    </a:lnT>
-                    <a:lnB w="9525" cap="flat" cmpd="sng" algn="ctr">
-                      <a:solidFill>
-                        <a:srgbClr val="DDD8CC"/>
-                      </a:solidFill>
-                      <a:prstDash val="solid"/>
-                      <a:round/>
-                      <a:headEnd type="none" w="med" len="med"/>
-                      <a:tailEnd type="none" w="med" len="med"/>
-                    </a:lnB>
-                    <a:solidFill>
-                      <a:srgbClr val="FFFFFF"/>
-                    </a:solidFill>
-                  </a:tcPr>
-                </a:tc>
-                <a:tc>
-                  <a:txBody>
-                    <a:bodyPr/>
-                    <a:lstStyle/>
-                    <a:p>
-                      <a:pPr algn="r" indent="0" marL="0">
-                        <a:buNone/>
-                      </a:pPr>
-                      <a:r>
-                        <a:rPr lang="en-US" sz="1300" dirty="0">
-                          <a:solidFill>
-                            <a:srgbClr val="1B2430"/>
-                          </a:solidFill>
-                        </a:rPr>
-                        <a:t>2020</a:t>
-                      </a:r>
-                      <a:endParaRPr lang="en-US" sz="1300" dirty="0"/>
-                    </a:p>
-                  </a:txBody>
-                  <a:tcPr marL="73152" marR="73152" marT="36576" marB="36576" anchor="ctr">
-                    <a:lnL w="9525" cap="flat" cmpd="sng" algn="ctr">
-                      <a:solidFill>
-                        <a:srgbClr val="DDD8CC"/>
-                      </a:solidFill>
-                      <a:prstDash val="solid"/>
-                      <a:round/>
-                      <a:headEnd type="none" w="med" len="med"/>
-                      <a:tailEnd type="none" w="med" len="med"/>
-                    </a:lnL>
-                    <a:lnR w="9525" cap="flat" cmpd="sng" algn="ctr">
-                      <a:solidFill>
-                        <a:srgbClr val="DDD8CC"/>
-                      </a:solidFill>
-                      <a:prstDash val="solid"/>
-                      <a:round/>
-                      <a:headEnd type="none" w="med" len="med"/>
-                      <a:tailEnd type="none" w="med" len="med"/>
-                    </a:lnR>
-                    <a:lnT w="9525" cap="flat" cmpd="sng" algn="ctr">
-                      <a:solidFill>
-                        <a:srgbClr val="DDD8CC"/>
-                      </a:solidFill>
-                      <a:prstDash val="solid"/>
-                      <a:round/>
-                      <a:headEnd type="none" w="med" len="med"/>
-                      <a:tailEnd type="none" w="med" len="med"/>
-                    </a:lnT>
-                    <a:lnB w="9525" cap="flat" cmpd="sng" algn="ctr">
-                      <a:solidFill>
-                        <a:srgbClr val="DDD8CC"/>
-                      </a:solidFill>
-                      <a:prstDash val="solid"/>
-                      <a:round/>
-                      <a:headEnd type="none" w="med" len="med"/>
-                      <a:tailEnd type="none" w="med" len="med"/>
-                    </a:lnB>
-                    <a:solidFill>
-                      <a:srgbClr val="FFFFFF"/>
-                    </a:solidFill>
-                  </a:tcPr>
-                </a:tc>
-                <a:tc>
-                  <a:txBody>
-                    <a:bodyPr/>
-                    <a:lstStyle/>
-                    <a:p>
-                      <a:pPr algn="r" indent="0" marL="0">
-                        <a:buNone/>
-                      </a:pPr>
-                      <a:r>
-                        <a:rPr lang="en-US" sz="1300" dirty="0">
-                          <a:solidFill>
-                            <a:srgbClr val="1B2430"/>
-                          </a:solidFill>
-                        </a:rPr>
-                        <a:t>45.000</a:t>
-                      </a:r>
-                      <a:endParaRPr lang="en-US" sz="1300" dirty="0"/>
-                    </a:p>
-                  </a:txBody>
-                  <a:tcPr marL="73152" marR="73152" marT="36576" marB="36576" anchor="ctr">
-                    <a:lnL w="9525" cap="flat" cmpd="sng" algn="ctr">
-                      <a:solidFill>
-                        <a:srgbClr val="DDD8CC"/>
-                      </a:solidFill>
-                      <a:prstDash val="solid"/>
-                      <a:round/>
-                      <a:headEnd type="none" w="med" len="med"/>
-                      <a:tailEnd type="none" w="med" len="med"/>
-                    </a:lnL>
-                    <a:lnR w="9525" cap="flat" cmpd="sng" algn="ctr">
-                      <a:solidFill>
-                        <a:srgbClr val="DDD8CC"/>
-                      </a:solidFill>
-                      <a:prstDash val="solid"/>
-                      <a:round/>
-                      <a:headEnd type="none" w="med" len="med"/>
-                      <a:tailEnd type="none" w="med" len="med"/>
-                    </a:lnR>
-                    <a:lnT w="9525" cap="flat" cmpd="sng" algn="ctr">
-                      <a:solidFill>
-                        <a:srgbClr val="DDD8CC"/>
-                      </a:solidFill>
-                      <a:prstDash val="solid"/>
-                      <a:round/>
-                      <a:headEnd type="none" w="med" len="med"/>
-                      <a:tailEnd type="none" w="med" len="med"/>
-                    </a:lnT>
-                    <a:lnB w="9525" cap="flat" cmpd="sng" algn="ctr">
-                      <a:solidFill>
-                        <a:srgbClr val="DDD8CC"/>
-                      </a:solidFill>
-                      <a:prstDash val="solid"/>
-                      <a:round/>
-                      <a:headEnd type="none" w="med" len="med"/>
-                      <a:tailEnd type="none" w="med" len="med"/>
-                    </a:lnB>
-                    <a:solidFill>
-                      <a:srgbClr val="FFFFFF"/>
-                    </a:solidFill>
-                  </a:tcPr>
-                </a:tc>
-                <a:tc>
-                  <a:txBody>
-                    <a:bodyPr/>
-                    <a:lstStyle/>
-                    <a:p>
-                      <a:pPr algn="l" indent="0" marL="0">
-                        <a:buNone/>
-                      </a:pPr>
-                      <a:r>
-                        <a:rPr lang="en-US" sz="1300" dirty="0">
-                          <a:solidFill>
-                            <a:srgbClr val="1B2430"/>
-                          </a:solidFill>
-                        </a:rPr>
-                        <a:t>Tasarım</a:t>
-                      </a:r>
-                      <a:endParaRPr lang="en-US" sz="1300" dirty="0"/>
-                    </a:p>
-                  </a:txBody>
-                  <a:tcPr marL="73152" marR="73152" marT="36576" marB="36576" anchor="ctr">
-                    <a:lnL w="9525" cap="flat" cmpd="sng" algn="ctr">
-                      <a:solidFill>
-                        <a:srgbClr val="DDD8CC"/>
-                      </a:solidFill>
-                      <a:prstDash val="solid"/>
-                      <a:round/>
-                      <a:headEnd type="none" w="med" len="med"/>
-                      <a:tailEnd type="none" w="med" len="med"/>
-                    </a:lnL>
-                    <a:lnR w="9525" cap="flat" cmpd="sng" algn="ctr">
-                      <a:solidFill>
-                        <a:srgbClr val="DDD8CC"/>
-                      </a:solidFill>
-                      <a:prstDash val="solid"/>
-                      <a:round/>
-                      <a:headEnd type="none" w="med" len="med"/>
-                      <a:tailEnd type="none" w="med" len="med"/>
-                    </a:lnR>
-                    <a:lnT w="9525" cap="flat" cmpd="sng" algn="ctr">
-                      <a:solidFill>
-                        <a:srgbClr val="DDD8CC"/>
-                      </a:solidFill>
-                      <a:prstDash val="solid"/>
-                      <a:round/>
-                      <a:headEnd type="none" w="med" len="med"/>
-                      <a:tailEnd type="none" w="med" len="med"/>
-                    </a:lnT>
-                    <a:lnB w="9525" cap="flat" cmpd="sng" algn="ctr">
-                      <a:solidFill>
-                        <a:srgbClr val="DDD8CC"/>
-                      </a:solidFill>
-                      <a:prstDash val="solid"/>
-                      <a:round/>
-                      <a:headEnd type="none" w="med" len="med"/>
-                      <a:tailEnd type="none" w="med" len="med"/>
-                    </a:lnB>
-                    <a:solidFill>
-                      <a:srgbClr val="FFFFFF"/>
-                    </a:solidFill>
-                  </a:tcPr>
-                </a:tc>
-              </a:tr>
-              <a:tr h="502920">
-                <a:tc>
-                  <a:txBody>
-                    <a:bodyPr/>
-                    <a:lstStyle/>
-                    <a:p>
-                      <a:pPr algn="l" indent="0" marL="0">
-                        <a:buNone/>
-                      </a:pPr>
-                      <a:r>
-                        <a:rPr lang="en-US" sz="1300" dirty="0">
-                          <a:solidFill>
-                            <a:srgbClr val="1B2430"/>
-                          </a:solidFill>
-                        </a:rPr>
-                        <a:t>TR Motor ofis ve fabrika binaları</a:t>
-                      </a:r>
-                      <a:endParaRPr lang="en-US" sz="1300" dirty="0"/>
-                    </a:p>
-                  </a:txBody>
-                  <a:tcPr marL="73152" marR="73152" marT="36576" marB="36576" anchor="ctr">
-                    <a:lnL w="9525" cap="flat" cmpd="sng" algn="ctr">
-                      <a:solidFill>
-                        <a:srgbClr val="DDD8CC"/>
-                      </a:solidFill>
-                      <a:prstDash val="solid"/>
-                      <a:round/>
-                      <a:headEnd type="none" w="med" len="med"/>
-                      <a:tailEnd type="none" w="med" len="med"/>
-                    </a:lnL>
-                    <a:lnR w="9525" cap="flat" cmpd="sng" algn="ctr">
-                      <a:solidFill>
-                        <a:srgbClr val="DDD8CC"/>
-                      </a:solidFill>
-                      <a:prstDash val="solid"/>
-                      <a:round/>
-                      <a:headEnd type="none" w="med" len="med"/>
-                      <a:tailEnd type="none" w="med" len="med"/>
-                    </a:lnR>
-                    <a:lnT w="9525" cap="flat" cmpd="sng" algn="ctr">
-                      <a:solidFill>
-                        <a:srgbClr val="DDD8CC"/>
-                      </a:solidFill>
-                      <a:prstDash val="solid"/>
-                      <a:round/>
-                      <a:headEnd type="none" w="med" len="med"/>
-                      <a:tailEnd type="none" w="med" len="med"/>
-                    </a:lnT>
-                    <a:lnB w="9525" cap="flat" cmpd="sng" algn="ctr">
-                      <a:solidFill>
-                        <a:srgbClr val="DDD8CC"/>
-                      </a:solidFill>
-                      <a:prstDash val="solid"/>
-                      <a:round/>
-                      <a:headEnd type="none" w="med" len="med"/>
-                      <a:tailEnd type="none" w="med" len="med"/>
-                    </a:lnB>
-                    <a:solidFill>
-                      <a:srgbClr val="FFFFFF"/>
-                    </a:solidFill>
-                  </a:tcPr>
-                </a:tc>
-                <a:tc>
-                  <a:txBody>
-                    <a:bodyPr/>
-                    <a:lstStyle/>
-                    <a:p>
-                      <a:pPr algn="r" indent="0" marL="0">
-                        <a:buNone/>
-                      </a:pPr>
-                      <a:r>
-                        <a:rPr lang="en-US" sz="1300" dirty="0">
-                          <a:solidFill>
-                            <a:srgbClr val="1B2430"/>
-                          </a:solidFill>
-                        </a:rPr>
-                        <a:t>2023</a:t>
-                      </a:r>
-                      <a:endParaRPr lang="en-US" sz="1300" dirty="0"/>
-                    </a:p>
-                  </a:txBody>
-                  <a:tcPr marL="73152" marR="73152" marT="36576" marB="36576" anchor="ctr">
-                    <a:lnL w="9525" cap="flat" cmpd="sng" algn="ctr">
-                      <a:solidFill>
-                        <a:srgbClr val="DDD8CC"/>
-                      </a:solidFill>
-                      <a:prstDash val="solid"/>
-                      <a:round/>
-                      <a:headEnd type="none" w="med" len="med"/>
-                      <a:tailEnd type="none" w="med" len="med"/>
-                    </a:lnL>
-                    <a:lnR w="9525" cap="flat" cmpd="sng" algn="ctr">
-                      <a:solidFill>
-                        <a:srgbClr val="DDD8CC"/>
-                      </a:solidFill>
-                      <a:prstDash val="solid"/>
-                      <a:round/>
-                      <a:headEnd type="none" w="med" len="med"/>
-                      <a:tailEnd type="none" w="med" len="med"/>
-                    </a:lnR>
-                    <a:lnT w="9525" cap="flat" cmpd="sng" algn="ctr">
-                      <a:solidFill>
-                        <a:srgbClr val="DDD8CC"/>
-                      </a:solidFill>
-                      <a:prstDash val="solid"/>
-                      <a:round/>
-                      <a:headEnd type="none" w="med" len="med"/>
-                      <a:tailEnd type="none" w="med" len="med"/>
-                    </a:lnT>
-                    <a:lnB w="9525" cap="flat" cmpd="sng" algn="ctr">
-                      <a:solidFill>
-                        <a:srgbClr val="DDD8CC"/>
-                      </a:solidFill>
-                      <a:prstDash val="solid"/>
-                      <a:round/>
-                      <a:headEnd type="none" w="med" len="med"/>
-                      <a:tailEnd type="none" w="med" len="med"/>
-                    </a:lnB>
-                    <a:solidFill>
-                      <a:srgbClr val="FFFFFF"/>
-                    </a:solidFill>
-                  </a:tcPr>
-                </a:tc>
-                <a:tc>
-                  <a:txBody>
-                    <a:bodyPr/>
-                    <a:lstStyle/>
-                    <a:p>
-                      <a:pPr algn="r" indent="0" marL="0">
-                        <a:buNone/>
-                      </a:pPr>
-                      <a:r>
-                        <a:rPr lang="en-US" sz="1300" dirty="0">
-                          <a:solidFill>
-                            <a:srgbClr val="1B2430"/>
-                          </a:solidFill>
-                        </a:rPr>
-                        <a:t>553.991</a:t>
-                      </a:r>
-                      <a:endParaRPr lang="en-US" sz="1300" dirty="0"/>
-                    </a:p>
-                  </a:txBody>
-                  <a:tcPr marL="73152" marR="73152" marT="36576" marB="36576" anchor="ctr">
-                    <a:lnL w="9525" cap="flat" cmpd="sng" algn="ctr">
-                      <a:solidFill>
-                        <a:srgbClr val="DDD8CC"/>
-                      </a:solidFill>
-                      <a:prstDash val="solid"/>
-                      <a:round/>
-                      <a:headEnd type="none" w="med" len="med"/>
-                      <a:tailEnd type="none" w="med" len="med"/>
-                    </a:lnL>
-                    <a:lnR w="9525" cap="flat" cmpd="sng" algn="ctr">
-                      <a:solidFill>
-                        <a:srgbClr val="DDD8CC"/>
-                      </a:solidFill>
-                      <a:prstDash val="solid"/>
-                      <a:round/>
-                      <a:headEnd type="none" w="med" len="med"/>
-                      <a:tailEnd type="none" w="med" len="med"/>
-                    </a:lnR>
-                    <a:lnT w="9525" cap="flat" cmpd="sng" algn="ctr">
-                      <a:solidFill>
-                        <a:srgbClr val="DDD8CC"/>
-                      </a:solidFill>
-                      <a:prstDash val="solid"/>
-                      <a:round/>
-                      <a:headEnd type="none" w="med" len="med"/>
-                      <a:tailEnd type="none" w="med" len="med"/>
-                    </a:lnT>
-                    <a:lnB w="9525" cap="flat" cmpd="sng" algn="ctr">
-                      <a:solidFill>
-                        <a:srgbClr val="DDD8CC"/>
-                      </a:solidFill>
-                      <a:prstDash val="solid"/>
-                      <a:round/>
-                      <a:headEnd type="none" w="med" len="med"/>
-                      <a:tailEnd type="none" w="med" len="med"/>
-                    </a:lnB>
-                    <a:solidFill>
-                      <a:srgbClr val="FFFFFF"/>
-                    </a:solidFill>
-                  </a:tcPr>
-                </a:tc>
-                <a:tc>
-                  <a:txBody>
-                    <a:bodyPr/>
-                    <a:lstStyle/>
-                    <a:p>
-                      <a:pPr algn="l" indent="0" marL="0">
-                        <a:buNone/>
-                      </a:pPr>
-                      <a:r>
-                        <a:rPr lang="en-US" sz="1300" dirty="0">
-                          <a:solidFill>
-                            <a:srgbClr val="1B2430"/>
-                          </a:solidFill>
-                        </a:rPr>
-                        <a:t>Tasarım</a:t>
-                      </a:r>
-                      <a:endParaRPr lang="en-US" sz="1300" dirty="0"/>
-                    </a:p>
-                  </a:txBody>
-                  <a:tcPr marL="73152" marR="73152" marT="36576" marB="36576" anchor="ctr">
+                  <a:tcPr marL="64008" marR="64008" marT="27432" marB="27432" anchor="ctr">
                     <a:lnL w="9525" cap="flat" cmpd="sng" algn="ctr">
                       <a:solidFill>
                         <a:srgbClr val="DDD8CC"/>
@@ -21472,7 +20961,54 @@
       </p:graphicFrame>
       <p:sp>
         <p:nvSpPr>
-          <p:cNvPr id="18" name="Text 13"/>
+          <p:cNvPr id="17" name="Text 10"/>
+          <p:cNvSpPr txBox="1"/>
+          <p:nvPr/>
+        </p:nvSpPr>
+        <p:spPr>
+          <a:xfrm>
+            <a:off x="6812280" y="5513832"/>
+            <a:ext cx="4830775" cy="502920"/>
+          </a:xfrm>
+          <a:prstGeom prst="rect">
+            <a:avLst/>
+          </a:prstGeom>
+          <a:noFill/>
+          <a:ln/>
+        </p:spPr>
+        <p:txBody>
+          <a:bodyPr wrap="square" lIns="0" tIns="0" rIns="0" bIns="0" rtlCol="0" anchor="t"/>
+          <a:lstStyle/>
+          <a:p>
+            <a:pPr indent="0" marL="0">
+              <a:buNone/>
+            </a:pPr>
+            <a:r>
+              <a:rPr lang="en-US" sz="1300" b="1" dirty="0">
+                <a:solidFill>
+                  <a:schemeClr val="tx2"/>
+                </a:solidFill>
+              </a:rPr>
+              <a:t>Savunma sanayinde ayrıca: </a:t>
+            </a:r>
+            <a:pPr indent="0" marL="0">
+              <a:buNone/>
+            </a:pPr>
+            <a:r>
+              <a:rPr lang="en-US" sz="1300" dirty="0">
+                <a:solidFill>
+                  <a:schemeClr val="tx1"/>
+                </a:solidFill>
+              </a:rPr>
+              <a:t>MKE Teknopark ve Genel Müdürlük Binası (2020), TR Motor ofis ve fabrika binaları (2023).</a:t>
+            </a:r>
+            <a:endParaRPr lang="en-US" sz="1300" dirty="0"/>
+          </a:p>
+        </p:txBody>
+      </p:sp>
+      <p:sp>
+        <p:nvSpPr>
+          <p:cNvPr id="18" name="Text 11"/>
           <p:cNvSpPr txBox="1"/>
           <p:nvPr/>
         </p:nvSpPr>
@@ -21500,7 +21036,7 @@
                   <a:schemeClr val="accent5"/>
                 </a:solidFill>
               </a:rPr>
-              <a:t>Kaynak: Belen &amp; Partners kurumsal portföyü (Ağustos 2025). Roller portföydeki gibidir.</a:t>
+              <a:t>Kaynak ve görseller: Belen &amp; Partners kurumsal portföyü (Ağustos 2025). Roller portföydeki gibidir.</a:t>
             </a:r>
             <a:endParaRPr lang="en-US" sz="1100" dirty="0"/>
           </a:p>

</xml_diff>